<commit_message>
feat: Add caption and subtitle to powerpoint value interpolation; update test reference pptx
</commit_message>
<xml_diff>
--- a/tests/fixtures/data/highlight/reference.pptx
+++ b/tests/fixtures/data/highlight/reference.pptx
@@ -205,7 +205,7 @@
           <a:p>
             <a:fld id="{58134BE1-65F2-4435-8B51-6A5EBDF683AE}" type="datetimeFigureOut">
               <a:rPr lang="en-US" smtClean="0"/>
-              <a:t>5/23/25</a:t>
+              <a:t>5/23/2025</a:t>
             </a:fld>
             <a:endParaRPr lang="en-US"/>
           </a:p>
@@ -888,7 +888,7 @@
           <a:p>
             <a:fld id="{846CE7D5-CF57-46EF-B807-FDD0502418D4}" type="datetimeFigureOut">
               <a:rPr lang="en-US" smtClean="0"/>
-              <a:t>5/23/25</a:t>
+              <a:t>5/23/2025</a:t>
             </a:fld>
             <a:endParaRPr lang="en-US"/>
           </a:p>
@@ -1400,7 +1400,7 @@
           <a:p>
             <a:r>
               <a:rPr lang="en-US" dirty="0"/>
-              <a:t>Partnership Program (if applicable)</a:t>
+              <a:t>{{ subtitle }}</a:t>
             </a:r>
           </a:p>
         </p:txBody>
@@ -2059,7 +2059,7 @@
                 <a:cs typeface="Arial"/>
                 <a:sym typeface="Arial"/>
               </a:rPr>
-              <a:t>{{caption}}</a:t>
+              <a:t>{{ caption }}</a:t>
             </a:r>
             <a:endParaRPr kumimoji="0" sz="1400" b="0" i="0" u="none" strike="noStrike" kern="0" cap="none" spc="0" normalizeH="0" baseline="0" noProof="0" dirty="0">
               <a:ln>
@@ -2311,8 +2311,8 @@
         </p:nvSpPr>
         <p:spPr>
           <a:xfrm>
-            <a:off x="7097767" y="4791544"/>
-            <a:ext cx="4658653" cy="1277273"/>
+            <a:off x="6932427" y="4791544"/>
+            <a:ext cx="4989335" cy="938719"/>
           </a:xfrm>
           <a:prstGeom prst="rect">
             <a:avLst/>
@@ -2420,59 +2420,7 @@
                 <a:cs typeface="+mn-cs"/>
                 <a:sym typeface="Arial"/>
               </a:rPr>
-              <a:t>Collaborating Institutions: [Some </a:t>
-            </a:r>
-            <a:r>
-              <a:rPr lang="en-US" sz="1100" kern="0" dirty="0">
-                <a:solidFill>
-                  <a:srgbClr val="000000"/>
-                </a:solidFill>
-                <a:sym typeface="Arial"/>
-              </a:rPr>
-              <a:t>laboratory</a:t>
-            </a:r>
-            <a:r>
-              <a:rPr kumimoji="0" lang="en-US" sz="1100" b="0" i="0" u="none" strike="noStrike" kern="0" cap="none" spc="0" normalizeH="0" baseline="0" noProof="0" dirty="0">
-                <a:ln>
-                  <a:noFill/>
-                </a:ln>
-                <a:solidFill>
-                  <a:srgbClr val="000000"/>
-                </a:solidFill>
-                <a:effectLst/>
-                <a:uLnTx/>
-                <a:uFillTx/>
-                <a:ea typeface="+mn-ea"/>
-                <a:cs typeface="+mn-cs"/>
-                <a:sym typeface="Arial"/>
-              </a:rPr>
-              <a:t>, some </a:t>
-            </a:r>
-            <a:r>
-              <a:rPr lang="en-US" sz="1100" kern="0" dirty="0">
-                <a:solidFill>
-                  <a:srgbClr val="000000"/>
-                </a:solidFill>
-                <a:sym typeface="Arial"/>
-              </a:rPr>
-              <a:t>university</a:t>
-            </a:r>
-            <a:r>
-              <a:rPr kumimoji="0" lang="en-US" sz="1100" b="0" i="0" u="none" strike="noStrike" kern="0" cap="none" spc="0" normalizeH="0" baseline="0" noProof="0" dirty="0">
-                <a:ln>
-                  <a:noFill/>
-                </a:ln>
-                <a:solidFill>
-                  <a:srgbClr val="000000"/>
-                </a:solidFill>
-                <a:effectLst/>
-                <a:uLnTx/>
-                <a:uFillTx/>
-                <a:ea typeface="+mn-ea"/>
-                <a:cs typeface="+mn-cs"/>
-                <a:sym typeface="Arial"/>
-              </a:rPr>
-              <a:t>, …]</a:t>
+              <a:t>Collaborating Institutions: {{ partners }}</a:t>
             </a:r>
           </a:p>
           <a:p>
@@ -2510,33 +2458,7 @@
                 <a:cs typeface="+mn-cs"/>
                 <a:sym typeface="Arial"/>
               </a:rPr>
-              <a:t>ASCR Program: [ECRP/</a:t>
-            </a:r>
-            <a:r>
-              <a:rPr lang="en-US" sz="1100" kern="0" dirty="0">
-                <a:solidFill>
-                  <a:srgbClr val="000000"/>
-                </a:solidFill>
-                <a:sym typeface="Arial"/>
-              </a:rPr>
-              <a:t>AI for Science</a:t>
-            </a:r>
-            <a:r>
-              <a:rPr kumimoji="0" lang="en-US" sz="1100" b="0" i="0" u="none" strike="noStrike" kern="0" cap="none" spc="0" normalizeH="0" baseline="0" noProof="0" dirty="0">
-                <a:ln>
-                  <a:noFill/>
-                </a:ln>
-                <a:solidFill>
-                  <a:srgbClr val="000000"/>
-                </a:solidFill>
-                <a:effectLst/>
-                <a:uLnTx/>
-                <a:uFillTx/>
-                <a:ea typeface="+mn-ea"/>
-                <a:cs typeface="+mn-cs"/>
-                <a:sym typeface="Arial"/>
-              </a:rPr>
-              <a:t>/etc.]</a:t>
+              <a:t>ASCR Program: {{ programs }}</a:t>
             </a:r>
           </a:p>
           <a:p>
@@ -2574,7 +2496,7 @@
                 <a:cs typeface="+mn-cs"/>
                 <a:sym typeface="Arial"/>
               </a:rPr>
-              <a:t>ASCR PM: [Program manager’s name (first and last)]</a:t>
+              <a:t>ASCR PM: {{ managers }}</a:t>
             </a:r>
           </a:p>
           <a:p>
@@ -2612,113 +2534,7 @@
                 <a:cs typeface="+mn-cs"/>
                 <a:sym typeface="Arial"/>
               </a:rPr>
-              <a:t>Publication(s) for this work: XYZ, et al., “This is a title of a publication,” </a:t>
-            </a:r>
-            <a:r>
-              <a:rPr kumimoji="0" lang="en-US" sz="1100" b="0" i="1" u="none" strike="noStrike" kern="0" cap="none" spc="0" normalizeH="0" baseline="0" noProof="0" dirty="0">
-                <a:ln>
-                  <a:noFill/>
-                </a:ln>
-                <a:solidFill>
-                  <a:srgbClr val="000000"/>
-                </a:solidFill>
-                <a:effectLst/>
-                <a:uLnTx/>
-                <a:uFillTx/>
-                <a:ea typeface="+mn-ea"/>
-                <a:cs typeface="+mn-cs"/>
-                <a:sym typeface="Arial"/>
-              </a:rPr>
-              <a:t>Journal or Conference Proceedings NN</a:t>
-            </a:r>
-            <a:r>
-              <a:rPr kumimoji="0" lang="en-US" sz="1100" b="0" i="0" u="none" strike="noStrike" kern="0" cap="none" spc="0" normalizeH="0" baseline="0" noProof="0" dirty="0">
-                <a:ln>
-                  <a:noFill/>
-                </a:ln>
-                <a:solidFill>
-                  <a:srgbClr val="000000"/>
-                </a:solidFill>
-                <a:effectLst/>
-                <a:uLnTx/>
-                <a:uFillTx/>
-                <a:ea typeface="+mn-ea"/>
-                <a:cs typeface="+mn-cs"/>
-                <a:sym typeface="Arial"/>
-              </a:rPr>
-              <a:t> (YYYY): MMMM. </a:t>
-            </a:r>
-            <a:r>
-              <a:rPr kumimoji="0" lang="en-US" sz="1100" b="0" i="0" u="none" strike="noStrike" kern="0" cap="none" spc="0" normalizeH="0" baseline="0" noProof="0" dirty="0" err="1">
-                <a:ln>
-                  <a:noFill/>
-                </a:ln>
-                <a:solidFill>
-                  <a:srgbClr val="000000"/>
-                </a:solidFill>
-                <a:effectLst/>
-                <a:uLnTx/>
-                <a:uFillTx/>
-                <a:ea typeface="+mn-ea"/>
-                <a:cs typeface="+mn-cs"/>
-                <a:sym typeface="Arial"/>
-              </a:rPr>
-              <a:t>doi:PP.PPPP</a:t>
-            </a:r>
-            <a:r>
-              <a:rPr kumimoji="0" lang="en-US" sz="1100" b="0" i="0" u="none" strike="noStrike" kern="0" cap="none" spc="0" normalizeH="0" baseline="0" noProof="0" dirty="0">
-                <a:ln>
-                  <a:noFill/>
-                </a:ln>
-                <a:solidFill>
-                  <a:srgbClr val="000000"/>
-                </a:solidFill>
-                <a:effectLst/>
-                <a:uLnTx/>
-                <a:uFillTx/>
-                <a:ea typeface="+mn-ea"/>
-                <a:cs typeface="+mn-cs"/>
-                <a:sym typeface="Arial"/>
-              </a:rPr>
-              <a:t>/P.PPPPPPPP.</a:t>
-            </a:r>
-          </a:p>
-          <a:p>
-            <a:pPr marL="0" marR="0" lvl="0" indent="0" algn="l" defTabSz="914400" rtl="0" eaLnBrk="1" fontAlgn="auto" latinLnBrk="0" hangingPunct="1">
-              <a:lnSpc>
-                <a:spcPct val="100000"/>
-              </a:lnSpc>
-              <a:spcBef>
-                <a:spcPts val="0"/>
-              </a:spcBef>
-              <a:spcAft>
-                <a:spcPts val="0"/>
-              </a:spcAft>
-              <a:buClr>
-                <a:srgbClr val="000000"/>
-              </a:buClr>
-              <a:buSzTx/>
-              <a:buFont typeface="Arial"/>
-              <a:buNone/>
-              <a:tabLst/>
-              <a:defRPr/>
-            </a:pPr>
-            <a:r>
-              <a:rPr kumimoji="0" lang="en-US" sz="1100" b="0" i="0" u="none" strike="noStrike" kern="0" cap="none" spc="0" normalizeH="0" baseline="0" noProof="0" dirty="0">
-                <a:ln>
-                  <a:noFill/>
-                </a:ln>
-                <a:solidFill>
-                  <a:srgbClr val="000000"/>
-                </a:solidFill>
-                <a:effectLst/>
-                <a:uLnTx/>
-                <a:uFillTx/>
-                <a:ea typeface="+mn-ea"/>
-                <a:cs typeface="+mn-cs"/>
-                <a:sym typeface="Arial"/>
-              </a:rPr>
-              <a:t>and/or Code Developed or Datasets.</a:t>
+              <a:t>Publication(s) for this work: {{ citation }}</a:t>
             </a:r>
           </a:p>
         </p:txBody>
@@ -3314,6 +3130,27 @@
 </file>
 
 <file path=customXml/item1.xml><?xml version="1.0" encoding="utf-8"?>
+<p:properties xmlns:p="http://schemas.microsoft.com/office/2006/metadata/properties" xmlns:xsi="http://www.w3.org/2001/XMLSchema-instance" xmlns:pc="http://schemas.microsoft.com/office/infopath/2007/PartnerControls">
+  <documentManagement>
+    <lcf76f155ced4ddcb4097134ff3c332f xmlns="d3abd939-9d94-49d1-925a-c93fb1ff4b6e">
+      <Terms xmlns="http://schemas.microsoft.com/office/infopath/2007/PartnerControls"/>
+    </lcf76f155ced4ddcb4097134ff3c332f>
+    <SubjectTags xmlns="d3abd939-9d94-49d1-925a-c93fb1ff4b6e" xsi:nil="true"/>
+    <TaxCatchAll xmlns="bc761791-33a0-47b7-8145-9d3c2515a3a0" xsi:nil="true"/>
+  </documentManagement>
+</p:properties>
+</file>
+
+<file path=customXml/item2.xml><?xml version="1.0" encoding="utf-8"?>
+<?mso-contentType ?>
+<FormTemplates xmlns="http://schemas.microsoft.com/sharepoint/v3/contenttype/forms">
+  <Display>DocumentLibraryForm</Display>
+  <Edit>DocumentLibraryForm</Edit>
+  <New>DocumentLibraryForm</New>
+</FormTemplates>
+</file>
+
+<file path=customXml/item3.xml><?xml version="1.0" encoding="utf-8"?>
 <ct:contentTypeSchema xmlns:ct="http://schemas.microsoft.com/office/2006/metadata/contentType" xmlns:ma="http://schemas.microsoft.com/office/2006/metadata/properties/metaAttributes" ct:_="" ma:_="" ma:contentTypeName="Document" ma:contentTypeID="0x010100D0BF6F177D6D67458FBB47B7752A5A77" ma:contentTypeVersion="14" ma:contentTypeDescription="Create a new document." ma:contentTypeScope="" ma:versionID="511b56ef837cb8094633f79cbf6101bb">
   <xsd:schema xmlns:xsd="http://www.w3.org/2001/XMLSchema" xmlns:xs="http://www.w3.org/2001/XMLSchema" xmlns:p="http://schemas.microsoft.com/office/2006/metadata/properties" xmlns:ns2="d3abd939-9d94-49d1-925a-c93fb1ff4b6e" xmlns:ns3="bc761791-33a0-47b7-8145-9d3c2515a3a0" targetNamespace="http://schemas.microsoft.com/office/2006/metadata/properties" ma:root="true" ma:fieldsID="a0782334ac6122055466205749466095" ns2:_="" ns3:_="">
     <xsd:import namespace="d3abd939-9d94-49d1-925a-c93fb1ff4b6e"/>
@@ -3555,28 +3392,32 @@
 </ct:contentTypeSchema>
 </file>
 
-<file path=customXml/item2.xml><?xml version="1.0" encoding="utf-8"?>
-<?mso-contentType ?>
-<FormTemplates xmlns="http://schemas.microsoft.com/sharepoint/v3/contenttype/forms">
-  <Display>DocumentLibraryForm</Display>
-  <Edit>DocumentLibraryForm</Edit>
-  <New>DocumentLibraryForm</New>
-</FormTemplates>
+<file path=customXml/itemProps1.xml><?xml version="1.0" encoding="utf-8"?>
+<ds:datastoreItem xmlns:ds="http://schemas.openxmlformats.org/officeDocument/2006/customXml" ds:itemID="{B0A43E79-5F32-4471-8B9A-F8FE298C9716}">
+  <ds:schemaRefs>
+    <ds:schemaRef ds:uri="http://schemas.microsoft.com/office/2006/metadata/properties"/>
+    <ds:schemaRef ds:uri="bc761791-33a0-47b7-8145-9d3c2515a3a0"/>
+    <ds:schemaRef ds:uri="http://purl.org/dc/terms/"/>
+    <ds:schemaRef ds:uri="http://schemas.microsoft.com/office/2006/documentManagement/types"/>
+    <ds:schemaRef ds:uri="http://schemas.openxmlformats.org/package/2006/metadata/core-properties"/>
+    <ds:schemaRef ds:uri="d3abd939-9d94-49d1-925a-c93fb1ff4b6e"/>
+    <ds:schemaRef ds:uri="http://purl.org/dc/elements/1.1/"/>
+    <ds:schemaRef ds:uri="http://schemas.microsoft.com/office/infopath/2007/PartnerControls"/>
+    <ds:schemaRef ds:uri="http://www.w3.org/XML/1998/namespace"/>
+    <ds:schemaRef ds:uri="http://purl.org/dc/dcmitype/"/>
+  </ds:schemaRefs>
+</ds:datastoreItem>
 </file>
 
-<file path=customXml/item3.xml><?xml version="1.0" encoding="utf-8"?>
-<p:properties xmlns:p="http://schemas.microsoft.com/office/2006/metadata/properties" xmlns:xsi="http://www.w3.org/2001/XMLSchema-instance" xmlns:pc="http://schemas.microsoft.com/office/infopath/2007/PartnerControls">
-  <documentManagement>
-    <lcf76f155ced4ddcb4097134ff3c332f xmlns="d3abd939-9d94-49d1-925a-c93fb1ff4b6e">
-      <Terms xmlns="http://schemas.microsoft.com/office/infopath/2007/PartnerControls"/>
-    </lcf76f155ced4ddcb4097134ff3c332f>
-    <SubjectTags xmlns="d3abd939-9d94-49d1-925a-c93fb1ff4b6e" xsi:nil="true"/>
-    <TaxCatchAll xmlns="bc761791-33a0-47b7-8145-9d3c2515a3a0" xsi:nil="true"/>
-  </documentManagement>
-</p:properties>
+<file path=customXml/itemProps2.xml><?xml version="1.0" encoding="utf-8"?>
+<ds:datastoreItem xmlns:ds="http://schemas.openxmlformats.org/officeDocument/2006/customXml" ds:itemID="{AA8EE7F5-A494-4A3A-8402-D6EC287A4FD9}">
+  <ds:schemaRefs>
+    <ds:schemaRef ds:uri="http://schemas.microsoft.com/sharepoint/v3/contenttype/forms"/>
+  </ds:schemaRefs>
+</ds:datastoreItem>
 </file>
 
-<file path=customXml/itemProps1.xml><?xml version="1.0" encoding="utf-8"?>
+<file path=customXml/itemProps3.xml><?xml version="1.0" encoding="utf-8"?>
 <ds:datastoreItem xmlns:ds="http://schemas.openxmlformats.org/officeDocument/2006/customXml" ds:itemID="{A9B585CC-6C58-4D0F-87F3-D826C458A205}">
   <ds:schemaRefs>
     <ds:schemaRef ds:uri="http://schemas.microsoft.com/office/2006/metadata/contentType"/>
@@ -3593,29 +3434,4 @@
     <ds:schemaRef ds:uri="http://schemas.microsoft.com/internal/obd"/>
   </ds:schemaRefs>
 </ds:datastoreItem>
-</file>
-
-<file path=customXml/itemProps2.xml><?xml version="1.0" encoding="utf-8"?>
-<ds:datastoreItem xmlns:ds="http://schemas.openxmlformats.org/officeDocument/2006/customXml" ds:itemID="{AA8EE7F5-A494-4A3A-8402-D6EC287A4FD9}">
-  <ds:schemaRefs>
-    <ds:schemaRef ds:uri="http://schemas.microsoft.com/sharepoint/v3/contenttype/forms"/>
-  </ds:schemaRefs>
-</ds:datastoreItem>
-</file>
-
-<file path=customXml/itemProps3.xml><?xml version="1.0" encoding="utf-8"?>
-<ds:datastoreItem xmlns:ds="http://schemas.openxmlformats.org/officeDocument/2006/customXml" ds:itemID="{B0A43E79-5F32-4471-8B9A-F8FE298C9716}">
-  <ds:schemaRefs>
-    <ds:schemaRef ds:uri="http://schemas.microsoft.com/office/2006/metadata/properties"/>
-    <ds:schemaRef ds:uri="bc761791-33a0-47b7-8145-9d3c2515a3a0"/>
-    <ds:schemaRef ds:uri="http://purl.org/dc/terms/"/>
-    <ds:schemaRef ds:uri="http://schemas.microsoft.com/office/2006/documentManagement/types"/>
-    <ds:schemaRef ds:uri="http://schemas.openxmlformats.org/package/2006/metadata/core-properties"/>
-    <ds:schemaRef ds:uri="d3abd939-9d94-49d1-925a-c93fb1ff4b6e"/>
-    <ds:schemaRef ds:uri="http://purl.org/dc/elements/1.1/"/>
-    <ds:schemaRef ds:uri="http://schemas.microsoft.com/office/infopath/2007/PartnerControls"/>
-    <ds:schemaRef ds:uri="http://www.w3.org/XML/1998/namespace"/>
-    <ds:schemaRef ds:uri="http://purl.org/dc/dcmitype/"/>
-  </ds:schemaRefs>
-</ds:datastoreItem>
 </file>
</xml_diff>

<commit_message>
tests: Prepare for working with XML and regex
</commit_message>
<xml_diff>
--- a/tests/fixtures/data/highlight/reference.pptx
+++ b/tests/fixtures/data/highlight/reference.pptx
@@ -205,7 +205,7 @@
           <a:p>
             <a:fld id="{58134BE1-65F2-4435-8B51-6A5EBDF683AE}" type="datetimeFigureOut">
               <a:rPr lang="en-US" smtClean="0"/>
-              <a:t>5/23/2025</a:t>
+              <a:t>5/25/2025</a:t>
             </a:fld>
             <a:endParaRPr lang="en-US"/>
           </a:p>
@@ -888,7 +888,7 @@
           <a:p>
             <a:fld id="{846CE7D5-CF57-46EF-B807-FDD0502418D4}" type="datetimeFigureOut">
               <a:rPr lang="en-US" smtClean="0"/>
-              <a:t>5/23/2025</a:t>
+              <a:t>5/25/2025</a:t>
             </a:fld>
             <a:endParaRPr lang="en-US"/>
           </a:p>
@@ -1582,7 +1582,7 @@
         <p:spPr>
           <a:xfrm>
             <a:off x="245185" y="1144497"/>
-            <a:ext cx="6453289" cy="1261884"/>
+            <a:ext cx="6453289" cy="615513"/>
           </a:xfrm>
           <a:prstGeom prst="rect">
             <a:avLst/>
@@ -1652,120 +1652,11 @@
               <a:defRPr/>
             </a:pPr>
             <a:r>
-              <a:rPr kumimoji="0" lang="en-US" sz="1400" b="0" i="0" u="none" strike="noStrike" kern="0" cap="none" spc="0" normalizeH="0" baseline="0" noProof="0" dirty="0">
-                <a:ln>
-                  <a:noFill/>
-                </a:ln>
-                <a:effectLst/>
-                <a:uLnTx/>
-                <a:uFillTx/>
-                <a:ea typeface="Arial"/>
+              <a:rPr lang="en-US" sz="1400" kern="0" dirty="0">
                 <a:cs typeface="Arial"/>
                 <a:sym typeface="Arial"/>
               </a:rPr>
-              <a:t>Bullet points</a:t>
-            </a:r>
-            <a:r>
-              <a:rPr lang="en-US" sz="1400" kern="0" dirty="0">
-                <a:ea typeface="Arial"/>
-                <a:cs typeface="Arial"/>
-                <a:sym typeface="Arial"/>
-              </a:rPr>
-              <a:t> </a:t>
-            </a:r>
-            <a:r>
-              <a:rPr kumimoji="0" lang="en-US" sz="1400" b="0" i="0" u="none" strike="noStrike" kern="0" cap="none" spc="0" normalizeH="0" baseline="0" noProof="0" dirty="0">
-                <a:ln>
-                  <a:noFill/>
-                </a:ln>
-                <a:effectLst/>
-                <a:uLnTx/>
-                <a:uFillTx/>
-                <a:ea typeface="Arial"/>
-                <a:cs typeface="Arial"/>
-                <a:sym typeface="Arial"/>
-              </a:rPr>
-              <a:t>explaining the science; provide a description of the background and the result/accomplishment.</a:t>
-            </a:r>
-          </a:p>
-          <a:p>
-            <a:pPr marL="285750" indent="-285750">
-              <a:buClr>
-                <a:srgbClr val="000000"/>
-              </a:buClr>
-              <a:buFont typeface="Arial" panose="020B0604020202020204" pitchFamily="34" charset="0"/>
-              <a:buChar char="•"/>
-              <a:defRPr/>
-            </a:pPr>
-            <a:r>
-              <a:rPr kumimoji="0" lang="en-US" sz="1400" b="0" i="0" u="none" strike="noStrike" kern="0" cap="none" spc="0" normalizeH="0" baseline="0" noProof="0" dirty="0">
-                <a:ln>
-                  <a:noFill/>
-                </a:ln>
-                <a:effectLst/>
-                <a:uLnTx/>
-                <a:uFillTx/>
-                <a:ea typeface="Arial"/>
-                <a:cs typeface="Arial"/>
-                <a:sym typeface="Arial"/>
-              </a:rPr>
-              <a:t>Make sure that it is clear what open science question you have answered, or made progress toward answering, along with the </a:t>
-            </a:r>
-            <a:r>
-              <a:rPr kumimoji="0" lang="en-US" sz="1400" b="0" i="1" u="none" strike="noStrike" kern="0" cap="none" spc="0" normalizeH="0" baseline="0" noProof="0" dirty="0">
-                <a:ln>
-                  <a:noFill/>
-                </a:ln>
-                <a:effectLst/>
-                <a:uLnTx/>
-                <a:uFillTx/>
-                <a:ea typeface="Arial"/>
-                <a:cs typeface="Arial"/>
-                <a:sym typeface="Arial"/>
-              </a:rPr>
-              <a:t>what</a:t>
-            </a:r>
-            <a:r>
-              <a:rPr kumimoji="0" lang="en-US" sz="1400" b="0" i="0" u="none" strike="noStrike" kern="0" cap="none" spc="0" normalizeH="0" baseline="0" noProof="0" dirty="0">
-                <a:ln>
-                  <a:noFill/>
-                </a:ln>
-                <a:effectLst/>
-                <a:uLnTx/>
-                <a:uFillTx/>
-                <a:ea typeface="Arial"/>
-                <a:cs typeface="Arial"/>
-                <a:sym typeface="Arial"/>
-              </a:rPr>
-              <a:t> and the </a:t>
-            </a:r>
-            <a:r>
-              <a:rPr kumimoji="0" lang="en-US" sz="1400" b="0" i="1" u="none" strike="noStrike" kern="0" cap="none" spc="0" normalizeH="0" baseline="0" noProof="0" dirty="0">
-                <a:ln>
-                  <a:noFill/>
-                </a:ln>
-                <a:effectLst/>
-                <a:uLnTx/>
-                <a:uFillTx/>
-                <a:ea typeface="Arial"/>
-                <a:cs typeface="Arial"/>
-                <a:sym typeface="Arial"/>
-              </a:rPr>
-              <a:t>how</a:t>
-            </a:r>
-            <a:r>
-              <a:rPr kumimoji="0" lang="en-US" sz="1400" b="0" i="0" u="none" strike="noStrike" kern="0" cap="none" spc="0" normalizeH="0" baseline="0" noProof="0" dirty="0">
-                <a:ln>
-                  <a:noFill/>
-                </a:ln>
-                <a:effectLst/>
-                <a:uLnTx/>
-                <a:uFillTx/>
-                <a:ea typeface="Arial"/>
-                <a:cs typeface="Arial"/>
-                <a:sym typeface="Arial"/>
-              </a:rPr>
-              <a:t>.</a:t>
+              <a:t>{{ achievement }}</a:t>
             </a:r>
             <a:endParaRPr kumimoji="0" sz="1400" b="0" i="0" u="none" strike="noStrike" kern="0" cap="none" spc="0" normalizeH="0" baseline="0" noProof="0" dirty="0">
               <a:ln>
@@ -1794,8 +1685,8 @@
         </p:nvSpPr>
         <p:spPr>
           <a:xfrm>
-            <a:off x="238508" y="2430113"/>
-            <a:ext cx="6693919" cy="1477287"/>
+            <a:off x="238507" y="2724485"/>
+            <a:ext cx="6693919" cy="615513"/>
           </a:xfrm>
           <a:prstGeom prst="rect">
             <a:avLst/>
@@ -1887,99 +1778,7 @@
                 <a:cs typeface="Arial"/>
                 <a:sym typeface="Arial"/>
               </a:rPr>
-              <a:t>Bullet points</a:t>
-            </a:r>
-            <a:r>
-              <a:rPr lang="en-US" sz="1400" kern="0" dirty="0">
-                <a:ea typeface="Arial"/>
-                <a:cs typeface="Arial"/>
-                <a:sym typeface="Arial"/>
-              </a:rPr>
-              <a:t> </a:t>
-            </a:r>
-            <a:r>
-              <a:rPr kumimoji="0" lang="en-US" sz="1400" b="0" i="0" u="none" strike="noStrike" kern="0" cap="none" spc="0" normalizeH="0" baseline="0" noProof="0" dirty="0">
-                <a:ln>
-                  <a:noFill/>
-                </a:ln>
-                <a:effectLst/>
-                <a:uLnTx/>
-                <a:uFillTx/>
-                <a:ea typeface="Arial"/>
-                <a:cs typeface="Arial"/>
-                <a:sym typeface="Arial"/>
-              </a:rPr>
-              <a:t>explaining the impact of the result/accomplishment.</a:t>
-            </a:r>
-          </a:p>
-          <a:p>
-            <a:pPr marL="285750" marR="0" lvl="0" indent="-285750" algn="l" defTabSz="914400" rtl="0" eaLnBrk="1" fontAlgn="auto" latinLnBrk="0" hangingPunct="1">
-              <a:lnSpc>
-                <a:spcPct val="100000"/>
-              </a:lnSpc>
-              <a:spcBef>
-                <a:spcPts val="0"/>
-              </a:spcBef>
-              <a:spcAft>
-                <a:spcPts val="0"/>
-              </a:spcAft>
-              <a:buClr>
-                <a:srgbClr val="000000"/>
-              </a:buClr>
-              <a:buSzTx/>
-              <a:buFont typeface="Arial" panose="020B0604020202020204" pitchFamily="34" charset="0"/>
-              <a:buChar char="•"/>
-              <a:tabLst/>
-              <a:defRPr/>
-            </a:pPr>
-            <a:r>
-              <a:rPr kumimoji="0" lang="en-US" sz="1400" b="0" i="0" u="none" strike="noStrike" kern="0" cap="none" spc="0" normalizeH="0" baseline="0" noProof="0" dirty="0">
-                <a:ln>
-                  <a:noFill/>
-                </a:ln>
-                <a:effectLst/>
-                <a:uLnTx/>
-                <a:uFillTx/>
-                <a:ea typeface="Arial"/>
-                <a:cs typeface="Arial"/>
-                <a:sym typeface="Arial"/>
-              </a:rPr>
-              <a:t>Impact on the field, impact across fields, and impact on society are all relevant. </a:t>
-            </a:r>
-          </a:p>
-          <a:p>
-            <a:pPr marL="285750" marR="0" lvl="0" indent="-285750" algn="l" defTabSz="914400" rtl="0" eaLnBrk="1" fontAlgn="auto" latinLnBrk="0" hangingPunct="1">
-              <a:lnSpc>
-                <a:spcPct val="100000"/>
-              </a:lnSpc>
-              <a:spcBef>
-                <a:spcPts val="0"/>
-              </a:spcBef>
-              <a:spcAft>
-                <a:spcPts val="0"/>
-              </a:spcAft>
-              <a:buClr>
-                <a:srgbClr val="000000"/>
-              </a:buClr>
-              <a:buSzTx/>
-              <a:buFont typeface="Arial" panose="020B0604020202020204" pitchFamily="34" charset="0"/>
-              <a:buChar char="•"/>
-              <a:tabLst/>
-              <a:defRPr/>
-            </a:pPr>
-            <a:r>
-              <a:rPr kumimoji="0" lang="en-US" sz="1400" b="0" i="0" u="none" strike="noStrike" kern="0" cap="none" spc="0" normalizeH="0" baseline="0" noProof="0" dirty="0">
-                <a:ln>
-                  <a:noFill/>
-                </a:ln>
-                <a:effectLst/>
-                <a:uLnTx/>
-                <a:uFillTx/>
-                <a:ea typeface="Arial"/>
-                <a:cs typeface="Arial"/>
-                <a:sym typeface="Arial"/>
-              </a:rPr>
-              <a:t>Highlight any collaborations with Industry and/or other agencies and/or other DOE programs. The impact can include items beyond those described in the referenced publication(s).</a:t>
+              <a:t>{{ impact }}</a:t>
             </a:r>
             <a:endParaRPr kumimoji="0" sz="1400" b="0" i="0" u="none" strike="noStrike" kern="0" cap="none" spc="0" normalizeH="0" baseline="0" noProof="0" dirty="0">
               <a:ln>
@@ -2128,8 +1927,8 @@
         </p:nvSpPr>
         <p:spPr>
           <a:xfrm>
-            <a:off x="204656" y="3889477"/>
-            <a:ext cx="6693919" cy="1046400"/>
+            <a:off x="238507" y="4304474"/>
+            <a:ext cx="6693919" cy="615513"/>
           </a:xfrm>
           <a:prstGeom prst="rect">
             <a:avLst/>
@@ -2221,68 +2020,7 @@
                 <a:cs typeface="Arial"/>
                 <a:sym typeface="Arial"/>
               </a:rPr>
-              <a:t>A few bullets related to the technical approach pursued.</a:t>
-            </a:r>
-            <a:endParaRPr lang="en-US" sz="1400" b="0" i="0" u="none" strike="noStrike" kern="0" cap="none" spc="0" normalizeH="0" baseline="0" noProof="0" dirty="0">
-              <a:ln>
-                <a:noFill/>
-              </a:ln>
-              <a:effectLst/>
-              <a:uLnTx/>
-              <a:uFillTx/>
-              <a:ea typeface="Arial"/>
-              <a:cs typeface="Arial"/>
-            </a:endParaRPr>
-          </a:p>
-          <a:p>
-            <a:pPr marL="285750" indent="-285750">
-              <a:buClr>
-                <a:srgbClr val="000000"/>
-              </a:buClr>
-              <a:buSzPts val="1400"/>
-              <a:buFont typeface="Arial"/>
-              <a:buChar char="•"/>
-              <a:defRPr/>
-            </a:pPr>
-            <a:r>
-              <a:rPr lang="en-US" sz="1400" kern="0" dirty="0">
-                <a:cs typeface="Arial"/>
-              </a:rPr>
-              <a:t>Address the challenges that were overcome to reach success.</a:t>
-            </a:r>
-          </a:p>
-          <a:p>
-            <a:pPr marL="285750" marR="0" lvl="0" indent="-285750" algn="l" defTabSz="914400" rtl="0" eaLnBrk="1" fontAlgn="auto" latinLnBrk="0" hangingPunct="1">
-              <a:lnSpc>
-                <a:spcPct val="100000"/>
-              </a:lnSpc>
-              <a:spcBef>
-                <a:spcPts val="0"/>
-              </a:spcBef>
-              <a:spcAft>
-                <a:spcPts val="0"/>
-              </a:spcAft>
-              <a:buClr>
-                <a:srgbClr val="000000"/>
-              </a:buClr>
-              <a:buSzPts val="1400"/>
-              <a:buFont typeface="Arial"/>
-              <a:buChar char="•"/>
-              <a:tabLst/>
-              <a:defRPr/>
-            </a:pPr>
-            <a:r>
-              <a:rPr kumimoji="0" lang="en-US" sz="1400" b="0" i="0" u="none" strike="noStrike" kern="0" cap="none" spc="0" normalizeH="0" baseline="0" noProof="0" dirty="0">
-                <a:ln>
-                  <a:noFill/>
-                </a:ln>
-                <a:effectLst/>
-                <a:uLnTx/>
-                <a:uFillTx/>
-                <a:cs typeface="Arial"/>
-                <a:sym typeface="Arial"/>
-              </a:rPr>
-              <a:t>Make it clear what is unique about the highlighted approach.</a:t>
+              <a:t>{{ technical }}</a:t>
             </a:r>
             <a:endParaRPr kumimoji="0" sz="1400" b="0" i="0" u="none" strike="noStrike" kern="0" cap="none" spc="0" normalizeH="0" baseline="0" noProof="0" dirty="0">
               <a:ln>
@@ -3130,27 +2868,6 @@
 </file>
 
 <file path=customXml/item1.xml><?xml version="1.0" encoding="utf-8"?>
-<p:properties xmlns:p="http://schemas.microsoft.com/office/2006/metadata/properties" xmlns:xsi="http://www.w3.org/2001/XMLSchema-instance" xmlns:pc="http://schemas.microsoft.com/office/infopath/2007/PartnerControls">
-  <documentManagement>
-    <lcf76f155ced4ddcb4097134ff3c332f xmlns="d3abd939-9d94-49d1-925a-c93fb1ff4b6e">
-      <Terms xmlns="http://schemas.microsoft.com/office/infopath/2007/PartnerControls"/>
-    </lcf76f155ced4ddcb4097134ff3c332f>
-    <SubjectTags xmlns="d3abd939-9d94-49d1-925a-c93fb1ff4b6e" xsi:nil="true"/>
-    <TaxCatchAll xmlns="bc761791-33a0-47b7-8145-9d3c2515a3a0" xsi:nil="true"/>
-  </documentManagement>
-</p:properties>
-</file>
-
-<file path=customXml/item2.xml><?xml version="1.0" encoding="utf-8"?>
-<?mso-contentType ?>
-<FormTemplates xmlns="http://schemas.microsoft.com/sharepoint/v3/contenttype/forms">
-  <Display>DocumentLibraryForm</Display>
-  <Edit>DocumentLibraryForm</Edit>
-  <New>DocumentLibraryForm</New>
-</FormTemplates>
-</file>
-
-<file path=customXml/item3.xml><?xml version="1.0" encoding="utf-8"?>
 <ct:contentTypeSchema xmlns:ct="http://schemas.microsoft.com/office/2006/metadata/contentType" xmlns:ma="http://schemas.microsoft.com/office/2006/metadata/properties/metaAttributes" ct:_="" ma:_="" ma:contentTypeName="Document" ma:contentTypeID="0x010100D0BF6F177D6D67458FBB47B7752A5A77" ma:contentTypeVersion="14" ma:contentTypeDescription="Create a new document." ma:contentTypeScope="" ma:versionID="511b56ef837cb8094633f79cbf6101bb">
   <xsd:schema xmlns:xsd="http://www.w3.org/2001/XMLSchema" xmlns:xs="http://www.w3.org/2001/XMLSchema" xmlns:p="http://schemas.microsoft.com/office/2006/metadata/properties" xmlns:ns2="d3abd939-9d94-49d1-925a-c93fb1ff4b6e" xmlns:ns3="bc761791-33a0-47b7-8145-9d3c2515a3a0" targetNamespace="http://schemas.microsoft.com/office/2006/metadata/properties" ma:root="true" ma:fieldsID="a0782334ac6122055466205749466095" ns2:_="" ns3:_="">
     <xsd:import namespace="d3abd939-9d94-49d1-925a-c93fb1ff4b6e"/>
@@ -3392,32 +3109,28 @@
 </ct:contentTypeSchema>
 </file>
 
-<file path=customXml/itemProps1.xml><?xml version="1.0" encoding="utf-8"?>
-<ds:datastoreItem xmlns:ds="http://schemas.openxmlformats.org/officeDocument/2006/customXml" ds:itemID="{B0A43E79-5F32-4471-8B9A-F8FE298C9716}">
-  <ds:schemaRefs>
-    <ds:schemaRef ds:uri="http://schemas.microsoft.com/office/2006/metadata/properties"/>
-    <ds:schemaRef ds:uri="bc761791-33a0-47b7-8145-9d3c2515a3a0"/>
-    <ds:schemaRef ds:uri="http://purl.org/dc/terms/"/>
-    <ds:schemaRef ds:uri="http://schemas.microsoft.com/office/2006/documentManagement/types"/>
-    <ds:schemaRef ds:uri="http://schemas.openxmlformats.org/package/2006/metadata/core-properties"/>
-    <ds:schemaRef ds:uri="d3abd939-9d94-49d1-925a-c93fb1ff4b6e"/>
-    <ds:schemaRef ds:uri="http://purl.org/dc/elements/1.1/"/>
-    <ds:schemaRef ds:uri="http://schemas.microsoft.com/office/infopath/2007/PartnerControls"/>
-    <ds:schemaRef ds:uri="http://www.w3.org/XML/1998/namespace"/>
-    <ds:schemaRef ds:uri="http://purl.org/dc/dcmitype/"/>
-  </ds:schemaRefs>
-</ds:datastoreItem>
+<file path=customXml/item2.xml><?xml version="1.0" encoding="utf-8"?>
+<?mso-contentType ?>
+<FormTemplates xmlns="http://schemas.microsoft.com/sharepoint/v3/contenttype/forms">
+  <Display>DocumentLibraryForm</Display>
+  <Edit>DocumentLibraryForm</Edit>
+  <New>DocumentLibraryForm</New>
+</FormTemplates>
 </file>
 
-<file path=customXml/itemProps2.xml><?xml version="1.0" encoding="utf-8"?>
-<ds:datastoreItem xmlns:ds="http://schemas.openxmlformats.org/officeDocument/2006/customXml" ds:itemID="{AA8EE7F5-A494-4A3A-8402-D6EC287A4FD9}">
-  <ds:schemaRefs>
-    <ds:schemaRef ds:uri="http://schemas.microsoft.com/sharepoint/v3/contenttype/forms"/>
-  </ds:schemaRefs>
-</ds:datastoreItem>
+<file path=customXml/item3.xml><?xml version="1.0" encoding="utf-8"?>
+<p:properties xmlns:p="http://schemas.microsoft.com/office/2006/metadata/properties" xmlns:xsi="http://www.w3.org/2001/XMLSchema-instance" xmlns:pc="http://schemas.microsoft.com/office/infopath/2007/PartnerControls">
+  <documentManagement>
+    <lcf76f155ced4ddcb4097134ff3c332f xmlns="d3abd939-9d94-49d1-925a-c93fb1ff4b6e">
+      <Terms xmlns="http://schemas.microsoft.com/office/infopath/2007/PartnerControls"/>
+    </lcf76f155ced4ddcb4097134ff3c332f>
+    <SubjectTags xmlns="d3abd939-9d94-49d1-925a-c93fb1ff4b6e" xsi:nil="true"/>
+    <TaxCatchAll xmlns="bc761791-33a0-47b7-8145-9d3c2515a3a0" xsi:nil="true"/>
+  </documentManagement>
+</p:properties>
 </file>
 
-<file path=customXml/itemProps3.xml><?xml version="1.0" encoding="utf-8"?>
+<file path=customXml/itemProps1.xml><?xml version="1.0" encoding="utf-8"?>
 <ds:datastoreItem xmlns:ds="http://schemas.openxmlformats.org/officeDocument/2006/customXml" ds:itemID="{A9B585CC-6C58-4D0F-87F3-D826C458A205}">
   <ds:schemaRefs>
     <ds:schemaRef ds:uri="http://schemas.microsoft.com/office/2006/metadata/contentType"/>
@@ -3434,4 +3147,29 @@
     <ds:schemaRef ds:uri="http://schemas.microsoft.com/internal/obd"/>
   </ds:schemaRefs>
 </ds:datastoreItem>
+</file>
+
+<file path=customXml/itemProps2.xml><?xml version="1.0" encoding="utf-8"?>
+<ds:datastoreItem xmlns:ds="http://schemas.openxmlformats.org/officeDocument/2006/customXml" ds:itemID="{AA8EE7F5-A494-4A3A-8402-D6EC287A4FD9}">
+  <ds:schemaRefs>
+    <ds:schemaRef ds:uri="http://schemas.microsoft.com/sharepoint/v3/contenttype/forms"/>
+  </ds:schemaRefs>
+</ds:datastoreItem>
+</file>
+
+<file path=customXml/itemProps3.xml><?xml version="1.0" encoding="utf-8"?>
+<ds:datastoreItem xmlns:ds="http://schemas.openxmlformats.org/officeDocument/2006/customXml" ds:itemID="{B0A43E79-5F32-4471-8B9A-F8FE298C9716}">
+  <ds:schemaRefs>
+    <ds:schemaRef ds:uri="http://schemas.microsoft.com/office/2006/metadata/properties"/>
+    <ds:schemaRef ds:uri="bc761791-33a0-47b7-8145-9d3c2515a3a0"/>
+    <ds:schemaRef ds:uri="http://purl.org/dc/terms/"/>
+    <ds:schemaRef ds:uri="http://schemas.microsoft.com/office/2006/documentManagement/types"/>
+    <ds:schemaRef ds:uri="http://schemas.openxmlformats.org/package/2006/metadata/core-properties"/>
+    <ds:schemaRef ds:uri="d3abd939-9d94-49d1-925a-c93fb1ff4b6e"/>
+    <ds:schemaRef ds:uri="http://purl.org/dc/elements/1.1/"/>
+    <ds:schemaRef ds:uri="http://schemas.microsoft.com/office/infopath/2007/PartnerControls"/>
+    <ds:schemaRef ds:uri="http://www.w3.org/XML/1998/namespace"/>
+    <ds:schemaRef ds:uri="http://purl.org/dc/dcmitype/"/>
+  </ds:schemaRefs>
+</ds:datastoreItem>
 </file>
</xml_diff>

<commit_message>
wip: Initial interpolation of bullets ISO PPTX export
</commit_message>
<xml_diff>
--- a/tests/fixtures/data/highlight/reference.pptx
+++ b/tests/fixtures/data/highlight/reference.pptx
@@ -205,7 +205,7 @@
           <a:p>
             <a:fld id="{58134BE1-65F2-4435-8B51-6A5EBDF683AE}" type="datetimeFigureOut">
               <a:rPr lang="en-US" smtClean="0"/>
-              <a:t>5/25/2025</a:t>
+              <a:t>5/29/2025</a:t>
             </a:fld>
             <a:endParaRPr lang="en-US"/>
           </a:p>
@@ -888,7 +888,7 @@
           <a:p>
             <a:fld id="{846CE7D5-CF57-46EF-B807-FDD0502418D4}" type="datetimeFigureOut">
               <a:rPr lang="en-US" smtClean="0"/>
-              <a:t>5/25/2025</a:t>
+              <a:t>5/29/2025</a:t>
             </a:fld>
             <a:endParaRPr lang="en-US"/>
           </a:p>
@@ -1656,18 +1656,8 @@
                 <a:cs typeface="Arial"/>
                 <a:sym typeface="Arial"/>
               </a:rPr>
-              <a:t>{{ achievement }}</a:t>
+              <a:t>{{achievement}}</a:t>
             </a:r>
-            <a:endParaRPr kumimoji="0" sz="1400" b="0" i="0" u="none" strike="noStrike" kern="0" cap="none" spc="0" normalizeH="0" baseline="0" noProof="0" dirty="0">
-              <a:ln>
-                <a:noFill/>
-              </a:ln>
-              <a:effectLst/>
-              <a:uLnTx/>
-              <a:uFillTx/>
-              <a:cs typeface="Arial"/>
-              <a:sym typeface="Arial"/>
-            </a:endParaRPr>
           </a:p>
         </p:txBody>
       </p:sp>
@@ -3110,15 +3100,6 @@
 </file>
 
 <file path=customXml/item2.xml><?xml version="1.0" encoding="utf-8"?>
-<?mso-contentType ?>
-<FormTemplates xmlns="http://schemas.microsoft.com/sharepoint/v3/contenttype/forms">
-  <Display>DocumentLibraryForm</Display>
-  <Edit>DocumentLibraryForm</Edit>
-  <New>DocumentLibraryForm</New>
-</FormTemplates>
-</file>
-
-<file path=customXml/item3.xml><?xml version="1.0" encoding="utf-8"?>
 <p:properties xmlns:p="http://schemas.microsoft.com/office/2006/metadata/properties" xmlns:xsi="http://www.w3.org/2001/XMLSchema-instance" xmlns:pc="http://schemas.microsoft.com/office/infopath/2007/PartnerControls">
   <documentManagement>
     <lcf76f155ced4ddcb4097134ff3c332f xmlns="d3abd939-9d94-49d1-925a-c93fb1ff4b6e">
@@ -3128,6 +3109,15 @@
     <TaxCatchAll xmlns="bc761791-33a0-47b7-8145-9d3c2515a3a0" xsi:nil="true"/>
   </documentManagement>
 </p:properties>
+</file>
+
+<file path=customXml/item3.xml><?xml version="1.0" encoding="utf-8"?>
+<?mso-contentType ?>
+<FormTemplates xmlns="http://schemas.microsoft.com/sharepoint/v3/contenttype/forms">
+  <Display>DocumentLibraryForm</Display>
+  <Edit>DocumentLibraryForm</Edit>
+  <New>DocumentLibraryForm</New>
+</FormTemplates>
 </file>
 
 <file path=customXml/itemProps1.xml><?xml version="1.0" encoding="utf-8"?>
@@ -3150,14 +3140,6 @@
 </file>
 
 <file path=customXml/itemProps2.xml><?xml version="1.0" encoding="utf-8"?>
-<ds:datastoreItem xmlns:ds="http://schemas.openxmlformats.org/officeDocument/2006/customXml" ds:itemID="{AA8EE7F5-A494-4A3A-8402-D6EC287A4FD9}">
-  <ds:schemaRefs>
-    <ds:schemaRef ds:uri="http://schemas.microsoft.com/sharepoint/v3/contenttype/forms"/>
-  </ds:schemaRefs>
-</ds:datastoreItem>
-</file>
-
-<file path=customXml/itemProps3.xml><?xml version="1.0" encoding="utf-8"?>
 <ds:datastoreItem xmlns:ds="http://schemas.openxmlformats.org/officeDocument/2006/customXml" ds:itemID="{B0A43E79-5F32-4471-8B9A-F8FE298C9716}">
   <ds:schemaRefs>
     <ds:schemaRef ds:uri="http://schemas.microsoft.com/office/2006/metadata/properties"/>
@@ -3172,4 +3154,12 @@
     <ds:schemaRef ds:uri="http://purl.org/dc/dcmitype/"/>
   </ds:schemaRefs>
 </ds:datastoreItem>
+</file>
+
+<file path=customXml/itemProps3.xml><?xml version="1.0" encoding="utf-8"?>
+<ds:datastoreItem xmlns:ds="http://schemas.openxmlformats.org/officeDocument/2006/customXml" ds:itemID="{AA8EE7F5-A494-4A3A-8402-D6EC287A4FD9}">
+  <ds:schemaRefs>
+    <ds:schemaRef ds:uri="http://schemas.microsoft.com/sharepoint/v3/contenttype/forms"/>
+  </ds:schemaRefs>
+</ds:datastoreItem>
 </file>
</xml_diff>

<commit_message>
wip: Fix PPTX repair issue and interpolate technical approach
</commit_message>
<xml_diff>
--- a/tests/fixtures/data/highlight/reference.pptx
+++ b/tests/fixtures/data/highlight/reference.pptx
@@ -1297,8 +1297,8 @@
         </p:nvSpPr>
         <p:spPr>
           <a:xfrm>
-            <a:off x="6932427" y="4720433"/>
-            <a:ext cx="4989335" cy="1348384"/>
+            <a:off x="7066844" y="4720433"/>
+            <a:ext cx="4854918" cy="1348384"/>
           </a:xfrm>
           <a:prstGeom prst="rect">
             <a:avLst/>
@@ -1384,7 +1384,7 @@
         </p:nvSpPr>
         <p:spPr>
           <a:xfrm>
-            <a:off x="320054" y="682853"/>
+            <a:off x="320054" y="626408"/>
             <a:ext cx="5068866" cy="369332"/>
           </a:xfrm>
           <a:prstGeom prst="rect">
@@ -1656,7 +1656,7 @@
                 <a:cs typeface="Arial"/>
                 <a:sym typeface="Arial"/>
               </a:rPr>
-              <a:t>{{achievement}}</a:t>
+              <a:t>{{ achievement }}</a:t>
             </a:r>
           </a:p>
         </p:txBody>
@@ -1967,35 +1967,14 @@
               </a:rPr>
               <a:t>Technical Approach</a:t>
             </a:r>
-            <a:endParaRPr kumimoji="0" sz="1400" b="0" i="0" u="none" strike="noStrike" kern="0" cap="none" spc="0" normalizeH="0" baseline="0" noProof="0" dirty="0">
-              <a:ln>
-                <a:noFill/>
-              </a:ln>
-              <a:effectLst/>
-              <a:uLnTx/>
-              <a:uFillTx/>
-              <a:cs typeface="Arial"/>
-              <a:sym typeface="Arial"/>
-            </a:endParaRPr>
-          </a:p>
-          <a:p>
-            <a:pPr marL="285750" marR="0" lvl="0" indent="-285750" algn="l" defTabSz="914400" rtl="0" eaLnBrk="1" fontAlgn="auto" latinLnBrk="0" hangingPunct="1">
-              <a:lnSpc>
-                <a:spcPct val="100000"/>
-              </a:lnSpc>
-              <a:spcBef>
-                <a:spcPts val="0"/>
-              </a:spcBef>
-              <a:spcAft>
-                <a:spcPts val="0"/>
-              </a:spcAft>
+          </a:p>
+          <a:p>
+            <a:pPr marL="285750" indent="-285750">
               <a:buClr>
                 <a:srgbClr val="000000"/>
               </a:buClr>
-              <a:buSzPts val="1400"/>
-              <a:buFont typeface="Arial"/>
+              <a:buFont typeface="Arial" panose="020B0604020202020204" pitchFamily="34" charset="0"/>
               <a:buChar char="•"/>
-              <a:tabLst/>
               <a:defRPr/>
             </a:pPr>
             <a:r>
@@ -2012,7 +1991,7 @@
               </a:rPr>
               <a:t>{{ technical }}</a:t>
             </a:r>
-            <a:endParaRPr kumimoji="0" sz="1400" b="0" i="0" u="none" strike="noStrike" kern="0" cap="none" spc="0" normalizeH="0" baseline="0" noProof="0" dirty="0">
+            <a:endParaRPr kumimoji="0" lang="en-US" sz="1400" b="0" i="0" u="none" strike="noStrike" kern="0" cap="none" spc="0" normalizeH="0" baseline="0" noProof="0" dirty="0">
               <a:ln>
                 <a:noFill/>
               </a:ln>
@@ -2039,8 +2018,8 @@
         </p:nvSpPr>
         <p:spPr>
           <a:xfrm>
-            <a:off x="6932427" y="4791544"/>
-            <a:ext cx="4989335" cy="938719"/>
+            <a:off x="7066844" y="4791544"/>
+            <a:ext cx="4854918" cy="938719"/>
           </a:xfrm>
           <a:prstGeom prst="rect">
             <a:avLst/>
@@ -2858,6 +2837,27 @@
 </file>
 
 <file path=customXml/item1.xml><?xml version="1.0" encoding="utf-8"?>
+<?mso-contentType ?>
+<FormTemplates xmlns="http://schemas.microsoft.com/sharepoint/v3/contenttype/forms">
+  <Display>DocumentLibraryForm</Display>
+  <Edit>DocumentLibraryForm</Edit>
+  <New>DocumentLibraryForm</New>
+</FormTemplates>
+</file>
+
+<file path=customXml/item2.xml><?xml version="1.0" encoding="utf-8"?>
+<p:properties xmlns:p="http://schemas.microsoft.com/office/2006/metadata/properties" xmlns:xsi="http://www.w3.org/2001/XMLSchema-instance" xmlns:pc="http://schemas.microsoft.com/office/infopath/2007/PartnerControls">
+  <documentManagement>
+    <lcf76f155ced4ddcb4097134ff3c332f xmlns="d3abd939-9d94-49d1-925a-c93fb1ff4b6e">
+      <Terms xmlns="http://schemas.microsoft.com/office/infopath/2007/PartnerControls"/>
+    </lcf76f155ced4ddcb4097134ff3c332f>
+    <SubjectTags xmlns="d3abd939-9d94-49d1-925a-c93fb1ff4b6e" xsi:nil="true"/>
+    <TaxCatchAll xmlns="bc761791-33a0-47b7-8145-9d3c2515a3a0" xsi:nil="true"/>
+  </documentManagement>
+</p:properties>
+</file>
+
+<file path=customXml/item3.xml><?xml version="1.0" encoding="utf-8"?>
 <ct:contentTypeSchema xmlns:ct="http://schemas.microsoft.com/office/2006/metadata/contentType" xmlns:ma="http://schemas.microsoft.com/office/2006/metadata/properties/metaAttributes" ct:_="" ma:_="" ma:contentTypeName="Document" ma:contentTypeID="0x010100D0BF6F177D6D67458FBB47B7752A5A77" ma:contentTypeVersion="14" ma:contentTypeDescription="Create a new document." ma:contentTypeScope="" ma:versionID="511b56ef837cb8094633f79cbf6101bb">
   <xsd:schema xmlns:xsd="http://www.w3.org/2001/XMLSchema" xmlns:xs="http://www.w3.org/2001/XMLSchema" xmlns:p="http://schemas.microsoft.com/office/2006/metadata/properties" xmlns:ns2="d3abd939-9d94-49d1-925a-c93fb1ff4b6e" xmlns:ns3="bc761791-33a0-47b7-8145-9d3c2515a3a0" targetNamespace="http://schemas.microsoft.com/office/2006/metadata/properties" ma:root="true" ma:fieldsID="a0782334ac6122055466205749466095" ns2:_="" ns3:_="">
     <xsd:import namespace="d3abd939-9d94-49d1-925a-c93fb1ff4b6e"/>
@@ -3099,42 +3099,10 @@
 </ct:contentTypeSchema>
 </file>
 
-<file path=customXml/item2.xml><?xml version="1.0" encoding="utf-8"?>
-<p:properties xmlns:p="http://schemas.microsoft.com/office/2006/metadata/properties" xmlns:xsi="http://www.w3.org/2001/XMLSchema-instance" xmlns:pc="http://schemas.microsoft.com/office/infopath/2007/PartnerControls">
-  <documentManagement>
-    <lcf76f155ced4ddcb4097134ff3c332f xmlns="d3abd939-9d94-49d1-925a-c93fb1ff4b6e">
-      <Terms xmlns="http://schemas.microsoft.com/office/infopath/2007/PartnerControls"/>
-    </lcf76f155ced4ddcb4097134ff3c332f>
-    <SubjectTags xmlns="d3abd939-9d94-49d1-925a-c93fb1ff4b6e" xsi:nil="true"/>
-    <TaxCatchAll xmlns="bc761791-33a0-47b7-8145-9d3c2515a3a0" xsi:nil="true"/>
-  </documentManagement>
-</p:properties>
-</file>
-
-<file path=customXml/item3.xml><?xml version="1.0" encoding="utf-8"?>
-<?mso-contentType ?>
-<FormTemplates xmlns="http://schemas.microsoft.com/sharepoint/v3/contenttype/forms">
-  <Display>DocumentLibraryForm</Display>
-  <Edit>DocumentLibraryForm</Edit>
-  <New>DocumentLibraryForm</New>
-</FormTemplates>
-</file>
-
 <file path=customXml/itemProps1.xml><?xml version="1.0" encoding="utf-8"?>
-<ds:datastoreItem xmlns:ds="http://schemas.openxmlformats.org/officeDocument/2006/customXml" ds:itemID="{A9B585CC-6C58-4D0F-87F3-D826C458A205}">
+<ds:datastoreItem xmlns:ds="http://schemas.openxmlformats.org/officeDocument/2006/customXml" ds:itemID="{AA8EE7F5-A494-4A3A-8402-D6EC287A4FD9}">
   <ds:schemaRefs>
-    <ds:schemaRef ds:uri="http://schemas.microsoft.com/office/2006/metadata/contentType"/>
-    <ds:schemaRef ds:uri="http://schemas.microsoft.com/office/2006/metadata/properties/metaAttributes"/>
-    <ds:schemaRef ds:uri="http://www.w3.org/2001/XMLSchema"/>
-    <ds:schemaRef ds:uri="http://schemas.microsoft.com/office/2006/metadata/properties"/>
-    <ds:schemaRef ds:uri="d3abd939-9d94-49d1-925a-c93fb1ff4b6e"/>
-    <ds:schemaRef ds:uri="bc761791-33a0-47b7-8145-9d3c2515a3a0"/>
-    <ds:schemaRef ds:uri="http://schemas.microsoft.com/office/2006/documentManagement/types"/>
-    <ds:schemaRef ds:uri="http://schemas.microsoft.com/office/infopath/2007/PartnerControls"/>
-    <ds:schemaRef ds:uri="http://schemas.openxmlformats.org/package/2006/metadata/core-properties"/>
-    <ds:schemaRef ds:uri="http://purl.org/dc/elements/1.1/"/>
-    <ds:schemaRef ds:uri="http://purl.org/dc/terms/"/>
-    <ds:schemaRef ds:uri="http://schemas.microsoft.com/internal/obd"/>
+    <ds:schemaRef ds:uri="http://schemas.microsoft.com/sharepoint/v3/contenttype/forms"/>
   </ds:schemaRefs>
 </ds:datastoreItem>
 </file>
@@ -3157,9 +3125,20 @@
 </file>
 
 <file path=customXml/itemProps3.xml><?xml version="1.0" encoding="utf-8"?>
-<ds:datastoreItem xmlns:ds="http://schemas.openxmlformats.org/officeDocument/2006/customXml" ds:itemID="{AA8EE7F5-A494-4A3A-8402-D6EC287A4FD9}">
+<ds:datastoreItem xmlns:ds="http://schemas.openxmlformats.org/officeDocument/2006/customXml" ds:itemID="{A9B585CC-6C58-4D0F-87F3-D826C458A205}">
   <ds:schemaRefs>
-    <ds:schemaRef ds:uri="http://schemas.microsoft.com/sharepoint/v3/contenttype/forms"/>
+    <ds:schemaRef ds:uri="http://schemas.microsoft.com/office/2006/metadata/contentType"/>
+    <ds:schemaRef ds:uri="http://schemas.microsoft.com/office/2006/metadata/properties/metaAttributes"/>
+    <ds:schemaRef ds:uri="http://www.w3.org/2001/XMLSchema"/>
+    <ds:schemaRef ds:uri="http://schemas.microsoft.com/office/2006/metadata/properties"/>
+    <ds:schemaRef ds:uri="d3abd939-9d94-49d1-925a-c93fb1ff4b6e"/>
+    <ds:schemaRef ds:uri="bc761791-33a0-47b7-8145-9d3c2515a3a0"/>
+    <ds:schemaRef ds:uri="http://schemas.microsoft.com/office/2006/documentManagement/types"/>
+    <ds:schemaRef ds:uri="http://schemas.microsoft.com/office/infopath/2007/PartnerControls"/>
+    <ds:schemaRef ds:uri="http://schemas.openxmlformats.org/package/2006/metadata/core-properties"/>
+    <ds:schemaRef ds:uri="http://purl.org/dc/elements/1.1/"/>
+    <ds:schemaRef ds:uri="http://purl.org/dc/terms/"/>
+    <ds:schemaRef ds:uri="http://schemas.microsoft.com/internal/obd"/>
   </ds:schemaRefs>
 </ds:datastoreItem>
 </file>
</xml_diff>

<commit_message>
feat: v1 PPTX export capability
</commit_message>
<xml_diff>
--- a/tests/fixtures/data/highlight/reference.pptx
+++ b/tests/fixtures/data/highlight/reference.pptx
@@ -205,7 +205,7 @@
           <a:p>
             <a:fld id="{58134BE1-65F2-4435-8B51-6A5EBDF683AE}" type="datetimeFigureOut">
               <a:rPr lang="en-US" smtClean="0"/>
-              <a:t>5/29/2025</a:t>
+              <a:t>5/30/25</a:t>
             </a:fld>
             <a:endParaRPr lang="en-US"/>
           </a:p>
@@ -607,6 +607,42 @@
           <a:chExt cx="0" cy="0"/>
         </a:xfrm>
       </p:grpSpPr>
+      <p:pic>
+        <p:nvPicPr>
+          <p:cNvPr id="5" name="Graphic 4">
+            <a:extLst>
+              <a:ext uri="{FF2B5EF4-FFF2-40B4-BE49-F238E27FC236}">
+                <a16:creationId xmlns:a16="http://schemas.microsoft.com/office/drawing/2014/main" id="{C4E134E1-BAAB-ABAB-63C2-F841ED85E0DF}"/>
+              </a:ext>
+            </a:extLst>
+          </p:cNvPr>
+          <p:cNvPicPr>
+            <a:picLocks noChangeAspect="1"/>
+          </p:cNvPicPr>
+          <p:nvPr userDrawn="1"/>
+        </p:nvPicPr>
+        <p:blipFill>
+          <a:blip r:embed="rId2">
+            <a:extLst>
+              <a:ext uri="{96DAC541-7B7A-43D3-8B79-37D633B846F1}">
+                <asvg:svgBlip xmlns:asvg="http://schemas.microsoft.com/office/drawing/2016/SVG/main" r:embed="rId3"/>
+              </a:ext>
+            </a:extLst>
+          </a:blip>
+          <a:stretch>
+            <a:fillRect/>
+          </a:stretch>
+        </p:blipFill>
+        <p:spPr>
+          <a:xfrm>
+            <a:off x="10634870" y="231578"/>
+            <a:ext cx="1347860" cy="324015"/>
+          </a:xfrm>
+          <a:prstGeom prst="rect">
+            <a:avLst/>
+          </a:prstGeom>
+        </p:spPr>
+      </p:pic>
       <p:sp>
         <p:nvSpPr>
           <p:cNvPr id="4" name="Rectangle 3">
@@ -668,7 +704,7 @@
           <p:nvPr userDrawn="1"/>
         </p:nvPicPr>
         <p:blipFill>
-          <a:blip r:embed="rId2">
+          <a:blip r:embed="rId4">
             <a:extLst>
               <a:ext uri="{28A0092B-C50C-407E-A947-70E740481C1C}">
                 <a14:useLocalDpi xmlns:a14="http://schemas.microsoft.com/office/drawing/2010/main"/>
@@ -888,7 +924,7 @@
           <a:p>
             <a:fld id="{846CE7D5-CF57-46EF-B807-FDD0502418D4}" type="datetimeFigureOut">
               <a:rPr lang="en-US" smtClean="0"/>
-              <a:t>5/29/2025</a:t>
+              <a:t>5/30/25</a:t>
             </a:fld>
             <a:endParaRPr lang="en-US"/>
           </a:p>
@@ -1385,7 +1421,7 @@
         <p:spPr>
           <a:xfrm>
             <a:off x="320054" y="626408"/>
-            <a:ext cx="5068866" cy="369332"/>
+            <a:ext cx="6746790" cy="369332"/>
           </a:xfrm>
           <a:prstGeom prst="rect">
             <a:avLst/>
@@ -1402,168 +1438,6 @@
               <a:rPr lang="en-US" dirty="0"/>
               <a:t>{{ subtitle }}</a:t>
             </a:r>
-          </a:p>
-        </p:txBody>
-      </p:sp>
-      <p:sp>
-        <p:nvSpPr>
-          <p:cNvPr id="5" name="Google Shape;31;p1">
-            <a:extLst>
-              <a:ext uri="{FF2B5EF4-FFF2-40B4-BE49-F238E27FC236}">
-                <a16:creationId xmlns:a16="http://schemas.microsoft.com/office/drawing/2014/main" id="{05753278-FC72-9EB0-E7BD-709A00592B82}"/>
-              </a:ext>
-            </a:extLst>
-          </p:cNvPr>
-          <p:cNvSpPr txBox="1"/>
-          <p:nvPr/>
-        </p:nvSpPr>
-        <p:spPr>
-          <a:xfrm>
-            <a:off x="9725064" y="136269"/>
-            <a:ext cx="1062321" cy="523220"/>
-          </a:xfrm>
-          <a:prstGeom prst="rect">
-            <a:avLst/>
-          </a:prstGeom>
-          <a:solidFill>
-            <a:schemeClr val="bg1"/>
-          </a:solidFill>
-          <a:ln>
-            <a:noFill/>
-          </a:ln>
-        </p:spPr>
-        <p:txBody>
-          <a:bodyPr spcFirstLastPara="1" wrap="square" lIns="91425" tIns="45700" rIns="91425" bIns="45700" anchor="t" anchorCtr="0">
-            <a:spAutoFit/>
-          </a:bodyPr>
-          <a:lstStyle/>
-          <a:p>
-            <a:pPr marL="0" marR="0" lvl="0" indent="0" algn="ctr" defTabSz="914400" rtl="0" eaLnBrk="1" fontAlgn="auto" latinLnBrk="0" hangingPunct="1">
-              <a:lnSpc>
-                <a:spcPct val="100000"/>
-              </a:lnSpc>
-              <a:spcBef>
-                <a:spcPts val="0"/>
-              </a:spcBef>
-              <a:spcAft>
-                <a:spcPts val="0"/>
-              </a:spcAft>
-              <a:buClr>
-                <a:srgbClr val="000000"/>
-              </a:buClr>
-              <a:buSzTx/>
-              <a:buFont typeface="Arial"/>
-              <a:buNone/>
-              <a:tabLst/>
-              <a:defRPr/>
-            </a:pPr>
-            <a:r>
-              <a:rPr kumimoji="0" lang="en-US" sz="1400" b="1" i="0" u="none" strike="noStrike" kern="0" cap="none" spc="0" normalizeH="0" baseline="0" noProof="0" dirty="0">
-                <a:ln>
-                  <a:noFill/>
-                </a:ln>
-                <a:effectLst/>
-                <a:uLnTx/>
-                <a:uFillTx/>
-                <a:latin typeface="Calibri"/>
-                <a:ea typeface="Calibri"/>
-                <a:cs typeface="Calibri"/>
-                <a:sym typeface="Calibri"/>
-              </a:rPr>
-              <a:t>Institution Logo #1</a:t>
-            </a:r>
-            <a:endParaRPr kumimoji="0" sz="1400" b="1" i="0" u="none" strike="noStrike" kern="0" cap="none" spc="0" normalizeH="0" baseline="0" noProof="0" dirty="0">
-              <a:ln>
-                <a:noFill/>
-              </a:ln>
-              <a:effectLst/>
-              <a:uLnTx/>
-              <a:uFillTx/>
-              <a:latin typeface="Arial"/>
-              <a:cs typeface="Arial"/>
-              <a:sym typeface="Arial"/>
-            </a:endParaRPr>
-          </a:p>
-        </p:txBody>
-      </p:sp>
-      <p:sp>
-        <p:nvSpPr>
-          <p:cNvPr id="6" name="Google Shape;32;p1">
-            <a:extLst>
-              <a:ext uri="{FF2B5EF4-FFF2-40B4-BE49-F238E27FC236}">
-                <a16:creationId xmlns:a16="http://schemas.microsoft.com/office/drawing/2014/main" id="{05E5441F-64DC-9F29-B6CA-621C0545A60E}"/>
-              </a:ext>
-            </a:extLst>
-          </p:cNvPr>
-          <p:cNvSpPr txBox="1"/>
-          <p:nvPr/>
-        </p:nvSpPr>
-        <p:spPr>
-          <a:xfrm>
-            <a:off x="10920409" y="131976"/>
-            <a:ext cx="1062321" cy="523220"/>
-          </a:xfrm>
-          <a:prstGeom prst="rect">
-            <a:avLst/>
-          </a:prstGeom>
-          <a:solidFill>
-            <a:schemeClr val="bg1"/>
-          </a:solidFill>
-          <a:ln>
-            <a:noFill/>
-          </a:ln>
-        </p:spPr>
-        <p:txBody>
-          <a:bodyPr spcFirstLastPara="1" wrap="square" lIns="91425" tIns="45700" rIns="91425" bIns="45700" anchor="t" anchorCtr="0">
-            <a:spAutoFit/>
-          </a:bodyPr>
-          <a:lstStyle/>
-          <a:p>
-            <a:pPr marL="0" marR="0" lvl="0" indent="0" algn="ctr" defTabSz="914400" rtl="0" eaLnBrk="1" fontAlgn="auto" latinLnBrk="0" hangingPunct="1">
-              <a:lnSpc>
-                <a:spcPct val="100000"/>
-              </a:lnSpc>
-              <a:spcBef>
-                <a:spcPts val="0"/>
-              </a:spcBef>
-              <a:spcAft>
-                <a:spcPts val="0"/>
-              </a:spcAft>
-              <a:buClr>
-                <a:srgbClr val="000000"/>
-              </a:buClr>
-              <a:buSzTx/>
-              <a:buFont typeface="Arial"/>
-              <a:buNone/>
-              <a:tabLst/>
-              <a:defRPr/>
-            </a:pPr>
-            <a:r>
-              <a:rPr kumimoji="0" lang="en-US" sz="1400" b="1" i="0" u="none" strike="noStrike" kern="0" cap="none" spc="0" normalizeH="0" baseline="0" noProof="0" dirty="0">
-                <a:ln>
-                  <a:noFill/>
-                </a:ln>
-                <a:effectLst/>
-                <a:uLnTx/>
-                <a:uFillTx/>
-                <a:latin typeface="Calibri"/>
-                <a:ea typeface="Calibri"/>
-                <a:cs typeface="Calibri"/>
-                <a:sym typeface="Calibri"/>
-              </a:rPr>
-              <a:t>Institution Logo #2</a:t>
-            </a:r>
-            <a:endParaRPr kumimoji="0" sz="1400" b="1" i="0" u="none" strike="noStrike" kern="0" cap="none" spc="0" normalizeH="0" baseline="0" noProof="0" dirty="0">
-              <a:ln>
-                <a:noFill/>
-              </a:ln>
-              <a:effectLst/>
-              <a:uLnTx/>
-              <a:uFillTx/>
-              <a:latin typeface="Arial"/>
-              <a:cs typeface="Arial"/>
-              <a:sym typeface="Arial"/>
-            </a:endParaRPr>
           </a:p>
         </p:txBody>
       </p:sp>
@@ -1675,7 +1549,7 @@
         </p:nvSpPr>
         <p:spPr>
           <a:xfrm>
-            <a:off x="238507" y="2724485"/>
+            <a:off x="238507" y="2825499"/>
             <a:ext cx="6693919" cy="615513"/>
           </a:xfrm>
           <a:prstGeom prst="rect">
@@ -1797,7 +1671,7 @@
         </p:nvSpPr>
         <p:spPr>
           <a:xfrm>
-            <a:off x="7467989" y="3692139"/>
+            <a:off x="7467989" y="3862267"/>
             <a:ext cx="4560581" cy="246181"/>
           </a:xfrm>
           <a:prstGeom prst="rect">
@@ -1887,7 +1761,7 @@
         </p:blipFill>
         <p:spPr>
           <a:xfrm>
-            <a:off x="7574798" y="824120"/>
+            <a:off x="7574798" y="994248"/>
             <a:ext cx="4346965" cy="2775343"/>
           </a:xfrm>
           <a:prstGeom prst="rect">
@@ -1917,7 +1791,7 @@
         </p:nvSpPr>
         <p:spPr>
           <a:xfrm>
-            <a:off x="238507" y="4304474"/>
+            <a:off x="238507" y="4506500"/>
             <a:ext cx="6693919" cy="615513"/>
           </a:xfrm>
           <a:prstGeom prst="rect">
@@ -2052,7 +1926,7 @@
               <a:defRPr/>
             </a:pPr>
             <a:r>
-              <a:rPr kumimoji="0" lang="en-US" sz="1100" b="0" i="0" u="none" strike="noStrike" kern="0" cap="none" spc="0" normalizeH="0" baseline="0" noProof="0" dirty="0">
+              <a:rPr kumimoji="0" lang="en-US" sz="1100" b="1" i="0" u="none" strike="noStrike" kern="0" cap="none" spc="0" normalizeH="0" baseline="0" noProof="0" dirty="0">
                 <a:ln>
                   <a:noFill/>
                 </a:ln>
@@ -2066,7 +1940,24 @@
                 <a:cs typeface="+mn-cs"/>
                 <a:sym typeface="Arial"/>
               </a:rPr>
-              <a:t>PI(s)/Facility Lead(s): </a:t>
+              <a:t>PI(s)/Facility Lead(s)</a:t>
+            </a:r>
+            <a:r>
+              <a:rPr kumimoji="0" lang="en-US" sz="1100" i="0" u="none" strike="noStrike" kern="0" cap="none" spc="0" normalizeH="0" baseline="0" noProof="0" dirty="0">
+                <a:ln>
+                  <a:noFill/>
+                </a:ln>
+                <a:solidFill>
+                  <a:srgbClr val="000000"/>
+                </a:solidFill>
+                <a:effectLst/>
+                <a:uLnTx/>
+                <a:uFillTx/>
+                <a:ea typeface="+mn-ea"/>
+                <a:cs typeface="+mn-cs"/>
+                <a:sym typeface="Arial"/>
+              </a:rPr>
+              <a:t>: </a:t>
             </a:r>
             <a:r>
               <a:rPr lang="en-US" sz="1100" kern="0" dirty="0">
@@ -2113,6 +2004,23 @@
               <a:defRPr/>
             </a:pPr>
             <a:r>
+              <a:rPr kumimoji="0" lang="en-US" sz="1100" b="1" i="0" u="none" strike="noStrike" kern="0" cap="none" spc="0" normalizeH="0" baseline="0" noProof="0" dirty="0">
+                <a:ln>
+                  <a:noFill/>
+                </a:ln>
+                <a:solidFill>
+                  <a:srgbClr val="000000"/>
+                </a:solidFill>
+                <a:effectLst/>
+                <a:uLnTx/>
+                <a:uFillTx/>
+                <a:ea typeface="+mn-ea"/>
+                <a:cs typeface="+mn-cs"/>
+                <a:sym typeface="Arial"/>
+              </a:rPr>
+              <a:t>Collaborating Institution(s)</a:t>
+            </a:r>
+            <a:r>
               <a:rPr kumimoji="0" lang="en-US" sz="1100" b="0" i="0" u="none" strike="noStrike" kern="0" cap="none" spc="0" normalizeH="0" baseline="0" noProof="0" dirty="0">
                 <a:ln>
                   <a:noFill/>
@@ -2127,8 +2035,22 @@
                 <a:cs typeface="+mn-cs"/>
                 <a:sym typeface="Arial"/>
               </a:rPr>
-              <a:t>Collaborating Institutions: {{ partners }}</a:t>
-            </a:r>
+              <a:t>: {{ partners }}</a:t>
+            </a:r>
+            <a:endParaRPr kumimoji="0" lang="en-US" sz="1100" b="1" i="0" u="none" strike="noStrike" kern="0" cap="none" spc="0" normalizeH="0" baseline="0" noProof="0" dirty="0">
+              <a:ln>
+                <a:noFill/>
+              </a:ln>
+              <a:solidFill>
+                <a:srgbClr val="000000"/>
+              </a:solidFill>
+              <a:effectLst/>
+              <a:uLnTx/>
+              <a:uFillTx/>
+              <a:ea typeface="+mn-ea"/>
+              <a:cs typeface="+mn-cs"/>
+              <a:sym typeface="Arial"/>
+            </a:endParaRPr>
           </a:p>
           <a:p>
             <a:pPr marL="0" marR="0" lvl="0" indent="0" algn="l" defTabSz="914400" rtl="0" eaLnBrk="1" fontAlgn="auto" latinLnBrk="0" hangingPunct="1">
@@ -2151,6 +2073,23 @@
               <a:defRPr/>
             </a:pPr>
             <a:r>
+              <a:rPr kumimoji="0" lang="en-US" sz="1100" b="1" i="0" u="none" strike="noStrike" kern="0" cap="none" spc="0" normalizeH="0" baseline="0" noProof="0" dirty="0">
+                <a:ln>
+                  <a:noFill/>
+                </a:ln>
+                <a:solidFill>
+                  <a:srgbClr val="000000"/>
+                </a:solidFill>
+                <a:effectLst/>
+                <a:uLnTx/>
+                <a:uFillTx/>
+                <a:ea typeface="+mn-ea"/>
+                <a:cs typeface="+mn-cs"/>
+                <a:sym typeface="Arial"/>
+              </a:rPr>
+              <a:t>ASCR Program</a:t>
+            </a:r>
+            <a:r>
               <a:rPr kumimoji="0" lang="en-US" sz="1100" b="0" i="0" u="none" strike="noStrike" kern="0" cap="none" spc="0" normalizeH="0" baseline="0" noProof="0" dirty="0">
                 <a:ln>
                   <a:noFill/>
@@ -2165,8 +2104,22 @@
                 <a:cs typeface="+mn-cs"/>
                 <a:sym typeface="Arial"/>
               </a:rPr>
-              <a:t>ASCR Program: {{ programs }}</a:t>
-            </a:r>
+              <a:t>: {{ programs }}</a:t>
+            </a:r>
+            <a:endParaRPr kumimoji="0" lang="en-US" sz="1100" b="1" i="0" u="none" strike="noStrike" kern="0" cap="none" spc="0" normalizeH="0" baseline="0" noProof="0" dirty="0">
+              <a:ln>
+                <a:noFill/>
+              </a:ln>
+              <a:solidFill>
+                <a:srgbClr val="000000"/>
+              </a:solidFill>
+              <a:effectLst/>
+              <a:uLnTx/>
+              <a:uFillTx/>
+              <a:ea typeface="+mn-ea"/>
+              <a:cs typeface="+mn-cs"/>
+              <a:sym typeface="Arial"/>
+            </a:endParaRPr>
           </a:p>
           <a:p>
             <a:pPr marL="0" marR="0" lvl="0" indent="0" algn="l" defTabSz="914400" rtl="0" eaLnBrk="1" fontAlgn="auto" latinLnBrk="0" hangingPunct="1">
@@ -2189,6 +2142,23 @@
               <a:defRPr/>
             </a:pPr>
             <a:r>
+              <a:rPr kumimoji="0" lang="en-US" sz="1100" b="1" i="0" u="none" strike="noStrike" kern="0" cap="none" spc="0" normalizeH="0" baseline="0" noProof="0" dirty="0">
+                <a:ln>
+                  <a:noFill/>
+                </a:ln>
+                <a:solidFill>
+                  <a:srgbClr val="000000"/>
+                </a:solidFill>
+                <a:effectLst/>
+                <a:uLnTx/>
+                <a:uFillTx/>
+                <a:ea typeface="+mn-ea"/>
+                <a:cs typeface="+mn-cs"/>
+                <a:sym typeface="Arial"/>
+              </a:rPr>
+              <a:t>ASCR PM</a:t>
+            </a:r>
+            <a:r>
               <a:rPr kumimoji="0" lang="en-US" sz="1100" b="0" i="0" u="none" strike="noStrike" kern="0" cap="none" spc="0" normalizeH="0" baseline="0" noProof="0" dirty="0">
                 <a:ln>
                   <a:noFill/>
@@ -2203,8 +2173,22 @@
                 <a:cs typeface="+mn-cs"/>
                 <a:sym typeface="Arial"/>
               </a:rPr>
-              <a:t>ASCR PM: {{ managers }}</a:t>
-            </a:r>
+              <a:t>: {{ managers }}</a:t>
+            </a:r>
+            <a:endParaRPr kumimoji="0" lang="en-US" sz="1100" b="1" i="0" u="none" strike="noStrike" kern="0" cap="none" spc="0" normalizeH="0" baseline="0" noProof="0" dirty="0">
+              <a:ln>
+                <a:noFill/>
+              </a:ln>
+              <a:solidFill>
+                <a:srgbClr val="000000"/>
+              </a:solidFill>
+              <a:effectLst/>
+              <a:uLnTx/>
+              <a:uFillTx/>
+              <a:ea typeface="+mn-ea"/>
+              <a:cs typeface="+mn-cs"/>
+              <a:sym typeface="Arial"/>
+            </a:endParaRPr>
           </a:p>
           <a:p>
             <a:pPr marL="0" marR="0" lvl="0" indent="0" algn="l" defTabSz="914400" rtl="0" eaLnBrk="1" fontAlgn="auto" latinLnBrk="0" hangingPunct="1">
@@ -2227,6 +2211,23 @@
               <a:defRPr/>
             </a:pPr>
             <a:r>
+              <a:rPr kumimoji="0" lang="en-US" sz="1100" b="1" i="0" u="none" strike="noStrike" kern="0" cap="none" spc="0" normalizeH="0" baseline="0" noProof="0" dirty="0">
+                <a:ln>
+                  <a:noFill/>
+                </a:ln>
+                <a:solidFill>
+                  <a:srgbClr val="000000"/>
+                </a:solidFill>
+                <a:effectLst/>
+                <a:uLnTx/>
+                <a:uFillTx/>
+                <a:ea typeface="+mn-ea"/>
+                <a:cs typeface="+mn-cs"/>
+                <a:sym typeface="Arial"/>
+              </a:rPr>
+              <a:t>Publication(s) for this work</a:t>
+            </a:r>
+            <a:r>
               <a:rPr kumimoji="0" lang="en-US" sz="1100" b="0" i="0" u="none" strike="noStrike" kern="0" cap="none" spc="0" normalizeH="0" baseline="0" noProof="0" dirty="0">
                 <a:ln>
                   <a:noFill/>
@@ -2241,7 +2242,7 @@
                 <a:cs typeface="+mn-cs"/>
                 <a:sym typeface="Arial"/>
               </a:rPr>
-              <a:t>Publication(s) for this work: {{ citation }}</a:t>
+              <a:t>: {{ citation }}</a:t>
             </a:r>
           </a:p>
         </p:txBody>
@@ -2837,27 +2838,6 @@
 </file>
 
 <file path=customXml/item1.xml><?xml version="1.0" encoding="utf-8"?>
-<?mso-contentType ?>
-<FormTemplates xmlns="http://schemas.microsoft.com/sharepoint/v3/contenttype/forms">
-  <Display>DocumentLibraryForm</Display>
-  <Edit>DocumentLibraryForm</Edit>
-  <New>DocumentLibraryForm</New>
-</FormTemplates>
-</file>
-
-<file path=customXml/item2.xml><?xml version="1.0" encoding="utf-8"?>
-<p:properties xmlns:p="http://schemas.microsoft.com/office/2006/metadata/properties" xmlns:xsi="http://www.w3.org/2001/XMLSchema-instance" xmlns:pc="http://schemas.microsoft.com/office/infopath/2007/PartnerControls">
-  <documentManagement>
-    <lcf76f155ced4ddcb4097134ff3c332f xmlns="d3abd939-9d94-49d1-925a-c93fb1ff4b6e">
-      <Terms xmlns="http://schemas.microsoft.com/office/infopath/2007/PartnerControls"/>
-    </lcf76f155ced4ddcb4097134ff3c332f>
-    <SubjectTags xmlns="d3abd939-9d94-49d1-925a-c93fb1ff4b6e" xsi:nil="true"/>
-    <TaxCatchAll xmlns="bc761791-33a0-47b7-8145-9d3c2515a3a0" xsi:nil="true"/>
-  </documentManagement>
-</p:properties>
-</file>
-
-<file path=customXml/item3.xml><?xml version="1.0" encoding="utf-8"?>
 <ct:contentTypeSchema xmlns:ct="http://schemas.microsoft.com/office/2006/metadata/contentType" xmlns:ma="http://schemas.microsoft.com/office/2006/metadata/properties/metaAttributes" ct:_="" ma:_="" ma:contentTypeName="Document" ma:contentTypeID="0x010100D0BF6F177D6D67458FBB47B7752A5A77" ma:contentTypeVersion="14" ma:contentTypeDescription="Create a new document." ma:contentTypeScope="" ma:versionID="511b56ef837cb8094633f79cbf6101bb">
   <xsd:schema xmlns:xsd="http://www.w3.org/2001/XMLSchema" xmlns:xs="http://www.w3.org/2001/XMLSchema" xmlns:p="http://schemas.microsoft.com/office/2006/metadata/properties" xmlns:ns2="d3abd939-9d94-49d1-925a-c93fb1ff4b6e" xmlns:ns3="bc761791-33a0-47b7-8145-9d3c2515a3a0" targetNamespace="http://schemas.microsoft.com/office/2006/metadata/properties" ma:root="true" ma:fieldsID="a0782334ac6122055466205749466095" ns2:_="" ns3:_="">
     <xsd:import namespace="d3abd939-9d94-49d1-925a-c93fb1ff4b6e"/>
@@ -3099,32 +3079,28 @@
 </ct:contentTypeSchema>
 </file>
 
-<file path=customXml/itemProps1.xml><?xml version="1.0" encoding="utf-8"?>
-<ds:datastoreItem xmlns:ds="http://schemas.openxmlformats.org/officeDocument/2006/customXml" ds:itemID="{AA8EE7F5-A494-4A3A-8402-D6EC287A4FD9}">
-  <ds:schemaRefs>
-    <ds:schemaRef ds:uri="http://schemas.microsoft.com/sharepoint/v3/contenttype/forms"/>
-  </ds:schemaRefs>
-</ds:datastoreItem>
+<file path=customXml/item2.xml><?xml version="1.0" encoding="utf-8"?>
+<?mso-contentType ?>
+<FormTemplates xmlns="http://schemas.microsoft.com/sharepoint/v3/contenttype/forms">
+  <Display>DocumentLibraryForm</Display>
+  <Edit>DocumentLibraryForm</Edit>
+  <New>DocumentLibraryForm</New>
+</FormTemplates>
 </file>
 
-<file path=customXml/itemProps2.xml><?xml version="1.0" encoding="utf-8"?>
-<ds:datastoreItem xmlns:ds="http://schemas.openxmlformats.org/officeDocument/2006/customXml" ds:itemID="{B0A43E79-5F32-4471-8B9A-F8FE298C9716}">
-  <ds:schemaRefs>
-    <ds:schemaRef ds:uri="http://schemas.microsoft.com/office/2006/metadata/properties"/>
-    <ds:schemaRef ds:uri="bc761791-33a0-47b7-8145-9d3c2515a3a0"/>
-    <ds:schemaRef ds:uri="http://purl.org/dc/terms/"/>
-    <ds:schemaRef ds:uri="http://schemas.microsoft.com/office/2006/documentManagement/types"/>
-    <ds:schemaRef ds:uri="http://schemas.openxmlformats.org/package/2006/metadata/core-properties"/>
-    <ds:schemaRef ds:uri="d3abd939-9d94-49d1-925a-c93fb1ff4b6e"/>
-    <ds:schemaRef ds:uri="http://purl.org/dc/elements/1.1/"/>
-    <ds:schemaRef ds:uri="http://schemas.microsoft.com/office/infopath/2007/PartnerControls"/>
-    <ds:schemaRef ds:uri="http://www.w3.org/XML/1998/namespace"/>
-    <ds:schemaRef ds:uri="http://purl.org/dc/dcmitype/"/>
-  </ds:schemaRefs>
-</ds:datastoreItem>
+<file path=customXml/item3.xml><?xml version="1.0" encoding="utf-8"?>
+<p:properties xmlns:p="http://schemas.microsoft.com/office/2006/metadata/properties" xmlns:xsi="http://www.w3.org/2001/XMLSchema-instance" xmlns:pc="http://schemas.microsoft.com/office/infopath/2007/PartnerControls">
+  <documentManagement>
+    <lcf76f155ced4ddcb4097134ff3c332f xmlns="d3abd939-9d94-49d1-925a-c93fb1ff4b6e">
+      <Terms xmlns="http://schemas.microsoft.com/office/infopath/2007/PartnerControls"/>
+    </lcf76f155ced4ddcb4097134ff3c332f>
+    <SubjectTags xmlns="d3abd939-9d94-49d1-925a-c93fb1ff4b6e" xsi:nil="true"/>
+    <TaxCatchAll xmlns="bc761791-33a0-47b7-8145-9d3c2515a3a0" xsi:nil="true"/>
+  </documentManagement>
+</p:properties>
 </file>
 
-<file path=customXml/itemProps3.xml><?xml version="1.0" encoding="utf-8"?>
+<file path=customXml/itemProps1.xml><?xml version="1.0" encoding="utf-8"?>
 <ds:datastoreItem xmlns:ds="http://schemas.openxmlformats.org/officeDocument/2006/customXml" ds:itemID="{A9B585CC-6C58-4D0F-87F3-D826C458A205}">
   <ds:schemaRefs>
     <ds:schemaRef ds:uri="http://schemas.microsoft.com/office/2006/metadata/contentType"/>
@@ -3141,4 +3117,29 @@
     <ds:schemaRef ds:uri="http://schemas.microsoft.com/internal/obd"/>
   </ds:schemaRefs>
 </ds:datastoreItem>
+</file>
+
+<file path=customXml/itemProps2.xml><?xml version="1.0" encoding="utf-8"?>
+<ds:datastoreItem xmlns:ds="http://schemas.openxmlformats.org/officeDocument/2006/customXml" ds:itemID="{AA8EE7F5-A494-4A3A-8402-D6EC287A4FD9}">
+  <ds:schemaRefs>
+    <ds:schemaRef ds:uri="http://schemas.microsoft.com/sharepoint/v3/contenttype/forms"/>
+  </ds:schemaRefs>
+</ds:datastoreItem>
+</file>
+
+<file path=customXml/itemProps3.xml><?xml version="1.0" encoding="utf-8"?>
+<ds:datastoreItem xmlns:ds="http://schemas.openxmlformats.org/officeDocument/2006/customXml" ds:itemID="{B0A43E79-5F32-4471-8B9A-F8FE298C9716}">
+  <ds:schemaRefs>
+    <ds:schemaRef ds:uri="http://schemas.microsoft.com/office/2006/metadata/properties"/>
+    <ds:schemaRef ds:uri="bc761791-33a0-47b7-8145-9d3c2515a3a0"/>
+    <ds:schemaRef ds:uri="http://purl.org/dc/terms/"/>
+    <ds:schemaRef ds:uri="http://schemas.microsoft.com/office/2006/documentManagement/types"/>
+    <ds:schemaRef ds:uri="http://schemas.openxmlformats.org/package/2006/metadata/core-properties"/>
+    <ds:schemaRef ds:uri="d3abd939-9d94-49d1-925a-c93fb1ff4b6e"/>
+    <ds:schemaRef ds:uri="http://purl.org/dc/elements/1.1/"/>
+    <ds:schemaRef ds:uri="http://schemas.microsoft.com/office/infopath/2007/PartnerControls"/>
+    <ds:schemaRef ds:uri="http://www.w3.org/XML/1998/namespace"/>
+    <ds:schemaRef ds:uri="http://purl.org/dc/dcmitype/"/>
+  </ds:schemaRefs>
+</ds:datastoreItem>
 </file>
</xml_diff>